<commit_message>
Security: Untrack competition PDFs and update .gitignore
</commit_message>
<xml_diff>
--- a/SecureCoating-Vision_Final_Defense_6min_Evidence_Aware.pptx
+++ b/SecureCoating-Vision_Final_Defense_6min_Evidence_Aware.pptx
@@ -114,6 +114,11 @@
       </a:defRPr>
     </a:lvl9pPr>
   </p:defaultTextStyle>
+  <p:extLst>
+    <p:ext uri="{EFAFB233-063F-42B5-8137-9DF3F51BA10A}">
+      <p15:sldGuideLst xmlns:p15="http://schemas.microsoft.com/office/powerpoint/2012/main"/>
+    </p:ext>
+  </p:extLst>
 </p:presentation>
 </file>
 
@@ -1462,8 +1467,8 @@
         </p:nvSpPr>
         <p:spPr>
           <a:xfrm>
-            <a:off x="6601968" y="476249"/>
-            <a:ext cx="5905500" cy="209550"/>
+            <a:off x="8421624" y="457199"/>
+            <a:ext cx="3346704" cy="257176"/>
           </a:xfrm>
           <a:prstGeom prst="rect">
             <a:avLst/>
@@ -1698,8 +1703,21 @@
                   <a:srgbClr val="5F6670"/>
                 </a:solidFill>
               </a:rPr>
-              <a:t>Team 71  •  Trịnh Hoàng Tú, HUFLIT</a:t>
-            </a:r>
+              <a:t>Team 71  •  Trịnh Hoàng Tú, H</a:t>
+            </a:r>
+            <a:r>
+              <a:rPr lang="en-US" sz="1350" b="0">
+                <a:solidFill>
+                  <a:srgbClr val="5F6670"/>
+                </a:solidFill>
+              </a:rPr>
+              <a:t>o Chi Minh City Foreign Language and Information Technology (HUFLIT)</a:t>
+            </a:r>
+            <a:endParaRPr sz="1350" b="0">
+              <a:solidFill>
+                <a:srgbClr val="5F6670"/>
+              </a:solidFill>
+            </a:endParaRPr>
           </a:p>
           <a:p>
             <a:pPr algn="l">
@@ -1888,7 +1906,7 @@
                   <a:srgbClr val="111318"/>
                 </a:solidFill>
               </a:rPr>
-              <a:t>Decision objective: prove a defensible inline inspection architecture — not a dashboard demo.</a:t>
+              <a:t>Decision objective: prove a defensible inline inspection architecture</a:t>
             </a:r>
           </a:p>
         </p:txBody>

</xml_diff>